<commit_message>
Adds new lectures and does post class cleanup
</commit_message>
<xml_diff>
--- a/lectures/075_web_services/The web, under the hood.pptx
+++ b/lectures/075_web_services/The web, under the hood.pptx
@@ -36,9 +36,9 @@
     <p:sldId id="287" r:id="rId30"/>
     <p:sldId id="288" r:id="rId31"/>
     <p:sldId id="283" r:id="rId32"/>
-    <p:sldId id="279" r:id="rId33"/>
-    <p:sldId id="281" r:id="rId34"/>
-    <p:sldId id="289" r:id="rId35"/>
+    <p:sldId id="289" r:id="rId33"/>
+    <p:sldId id="279" r:id="rId34"/>
+    <p:sldId id="281" r:id="rId35"/>
     <p:sldId id="285" r:id="rId36"/>
     <p:sldId id="284" r:id="rId37"/>
     <p:sldId id="286" r:id="rId38"/>
@@ -1120,7 +1120,7 @@
           <a:p>
             <a:fld id="{5892DAFE-CDAC-4B0E-AD8C-F5134B67DF4E}" type="datetimeFigureOut">
               <a:rPr lang="en-US" smtClean="0"/>
-              <a:t>2/10/26</a:t>
+              <a:t>8/9/26</a:t>
             </a:fld>
             <a:endParaRPr lang="en-US"/>
           </a:p>
@@ -1318,7 +1318,7 @@
           <a:p>
             <a:fld id="{5892DAFE-CDAC-4B0E-AD8C-F5134B67DF4E}" type="datetimeFigureOut">
               <a:rPr lang="en-US" smtClean="0"/>
-              <a:t>2/10/26</a:t>
+              <a:t>8/9/26</a:t>
             </a:fld>
             <a:endParaRPr lang="en-US"/>
           </a:p>
@@ -1526,7 +1526,7 @@
           <a:p>
             <a:fld id="{5892DAFE-CDAC-4B0E-AD8C-F5134B67DF4E}" type="datetimeFigureOut">
               <a:rPr lang="en-US" smtClean="0"/>
-              <a:t>2/10/26</a:t>
+              <a:t>8/9/26</a:t>
             </a:fld>
             <a:endParaRPr lang="en-US"/>
           </a:p>
@@ -1724,7 +1724,7 @@
           <a:p>
             <a:fld id="{5892DAFE-CDAC-4B0E-AD8C-F5134B67DF4E}" type="datetimeFigureOut">
               <a:rPr lang="en-US" smtClean="0"/>
-              <a:t>2/10/26</a:t>
+              <a:t>8/9/26</a:t>
             </a:fld>
             <a:endParaRPr lang="en-US"/>
           </a:p>
@@ -1999,7 +1999,7 @@
           <a:p>
             <a:fld id="{5892DAFE-CDAC-4B0E-AD8C-F5134B67DF4E}" type="datetimeFigureOut">
               <a:rPr lang="en-US" smtClean="0"/>
-              <a:t>2/10/26</a:t>
+              <a:t>8/9/26</a:t>
             </a:fld>
             <a:endParaRPr lang="en-US"/>
           </a:p>
@@ -2264,7 +2264,7 @@
           <a:p>
             <a:fld id="{5892DAFE-CDAC-4B0E-AD8C-F5134B67DF4E}" type="datetimeFigureOut">
               <a:rPr lang="en-US" smtClean="0"/>
-              <a:t>2/10/26</a:t>
+              <a:t>8/9/26</a:t>
             </a:fld>
             <a:endParaRPr lang="en-US"/>
           </a:p>
@@ -2676,7 +2676,7 @@
           <a:p>
             <a:fld id="{5892DAFE-CDAC-4B0E-AD8C-F5134B67DF4E}" type="datetimeFigureOut">
               <a:rPr lang="en-US" smtClean="0"/>
-              <a:t>2/10/26</a:t>
+              <a:t>8/9/26</a:t>
             </a:fld>
             <a:endParaRPr lang="en-US"/>
           </a:p>
@@ -2817,7 +2817,7 @@
           <a:p>
             <a:fld id="{5892DAFE-CDAC-4B0E-AD8C-F5134B67DF4E}" type="datetimeFigureOut">
               <a:rPr lang="en-US" smtClean="0"/>
-              <a:t>2/10/26</a:t>
+              <a:t>8/9/26</a:t>
             </a:fld>
             <a:endParaRPr lang="en-US"/>
           </a:p>
@@ -2930,7 +2930,7 @@
           <a:p>
             <a:fld id="{5892DAFE-CDAC-4B0E-AD8C-F5134B67DF4E}" type="datetimeFigureOut">
               <a:rPr lang="en-US" smtClean="0"/>
-              <a:t>2/10/26</a:t>
+              <a:t>8/9/26</a:t>
             </a:fld>
             <a:endParaRPr lang="en-US"/>
           </a:p>
@@ -3241,7 +3241,7 @@
           <a:p>
             <a:fld id="{5892DAFE-CDAC-4B0E-AD8C-F5134B67DF4E}" type="datetimeFigureOut">
               <a:rPr lang="en-US" smtClean="0"/>
-              <a:t>2/10/26</a:t>
+              <a:t>8/9/26</a:t>
             </a:fld>
             <a:endParaRPr lang="en-US"/>
           </a:p>
@@ -3529,7 +3529,7 @@
           <a:p>
             <a:fld id="{5892DAFE-CDAC-4B0E-AD8C-F5134B67DF4E}" type="datetimeFigureOut">
               <a:rPr lang="en-US" smtClean="0"/>
-              <a:t>2/10/26</a:t>
+              <a:t>8/9/26</a:t>
             </a:fld>
             <a:endParaRPr lang="en-US"/>
           </a:p>
@@ -3775,7 +3775,7 @@
           <a:p>
             <a:fld id="{5892DAFE-CDAC-4B0E-AD8C-F5134B67DF4E}" type="datetimeFigureOut">
               <a:rPr lang="en-US" smtClean="0"/>
-              <a:t>2/10/26</a:t>
+              <a:t>8/9/26</a:t>
             </a:fld>
             <a:endParaRPr lang="en-US"/>
           </a:p>
@@ -7871,6 +7871,9 @@
                     <a:lumMod val="50000"/>
                   </a:schemeClr>
                 </a:solidFill>
+                <a:highlight>
+                  <a:srgbClr val="FFFF00"/>
+                </a:highlight>
                 <a:latin typeface="Arial" panose="020B0604020202020204" pitchFamily="34" charset="0"/>
               </a:rPr>
               <a:t>if __name__ == '__main__’:</a:t>
@@ -7900,6 +7903,9 @@
                     <a:lumMod val="50000"/>
                   </a:schemeClr>
                 </a:solidFill>
+                <a:highlight>
+                  <a:srgbClr val="FFFF00"/>
+                </a:highlight>
                 <a:latin typeface="Arial" panose="020B0604020202020204" pitchFamily="34" charset="0"/>
               </a:rPr>
               <a:t>    print(</a:t>
@@ -7911,6 +7917,9 @@
                     <a:lumMod val="50000"/>
                   </a:schemeClr>
                 </a:solidFill>
+                <a:highlight>
+                  <a:srgbClr val="FFFF00"/>
+                </a:highlight>
                 <a:latin typeface="Arial" panose="020B0604020202020204" pitchFamily="34" charset="0"/>
               </a:rPr>
               <a:t>hello_world</a:t>
@@ -7922,6 +7931,9 @@
                     <a:lumMod val="50000"/>
                   </a:schemeClr>
                 </a:solidFill>
+                <a:highlight>
+                  <a:srgbClr val="FFFF00"/>
+                </a:highlight>
                 <a:latin typeface="Arial" panose="020B0604020202020204" pitchFamily="34" charset="0"/>
               </a:rPr>
               <a:t>())</a:t>
@@ -7936,6 +7948,9 @@
                 </a:schemeClr>
               </a:solidFill>
               <a:effectLst/>
+              <a:highlight>
+                <a:srgbClr val="FFFF00"/>
+              </a:highlight>
               <a:latin typeface="Arial" panose="020B0604020202020204" pitchFamily="34" charset="0"/>
             </a:endParaRPr>
           </a:p>
@@ -8559,7 +8574,23 @@
                 </a:highlight>
                 <a:latin typeface="Roboto Mono" panose="00000009000000000000" pitchFamily="49" charset="0"/>
               </a:rPr>
-              <a:t> flask </a:t>
+              <a:t> </a:t>
+            </a:r>
+            <a:r>
+              <a:rPr kumimoji="0" lang="en-US" altLang="en-US" sz="1600" b="0" i="0" u="none" strike="noStrike" cap="none" normalizeH="0" baseline="0" dirty="0" err="1">
+                <a:ln>
+                  <a:noFill/>
+                </a:ln>
+                <a:solidFill>
+                  <a:srgbClr val="37474F"/>
+                </a:solidFill>
+                <a:effectLst/>
+                <a:highlight>
+                  <a:srgbClr val="FFFF00"/>
+                </a:highlight>
+                <a:latin typeface="Roboto Mono" panose="00000009000000000000" pitchFamily="49" charset="0"/>
+              </a:rPr>
+              <a:t>fastapi</a:t>
             </a:r>
             <a:r>
               <a:rPr kumimoji="0" lang="en-US" altLang="en-US" sz="1600" b="0" i="0" u="none" strike="noStrike" cap="none" normalizeH="0" baseline="0" dirty="0">
@@ -8567,7 +8598,7 @@
                   <a:noFill/>
                 </a:ln>
                 <a:solidFill>
-                  <a:srgbClr val="3F51B5"/>
+                  <a:srgbClr val="37474F"/>
                 </a:solidFill>
                 <a:effectLst/>
                 <a:highlight>
@@ -8575,7 +8606,7 @@
                 </a:highlight>
                 <a:latin typeface="Roboto Mono" panose="00000009000000000000" pitchFamily="49" charset="0"/>
               </a:rPr>
-              <a:t>import</a:t>
+              <a:t> </a:t>
             </a:r>
             <a:r>
               <a:rPr kumimoji="0" lang="en-US" altLang="en-US" sz="1600" b="0" i="0" u="none" strike="noStrike" cap="none" normalizeH="0" baseline="0" dirty="0">
@@ -8583,7 +8614,7 @@
                   <a:noFill/>
                 </a:ln>
                 <a:solidFill>
-                  <a:srgbClr val="37474F"/>
+                  <a:srgbClr val="3F51B5"/>
                 </a:solidFill>
                 <a:effectLst/>
                 <a:highlight>
@@ -8591,7 +8622,55 @@
                 </a:highlight>
                 <a:latin typeface="Roboto Mono" panose="00000009000000000000" pitchFamily="49" charset="0"/>
               </a:rPr>
-              <a:t> Flask </a:t>
+              <a:t>import</a:t>
+            </a:r>
+            <a:r>
+              <a:rPr kumimoji="0" lang="en-US" altLang="en-US" sz="1600" b="0" i="0" u="none" strike="noStrike" cap="none" normalizeH="0" baseline="0" dirty="0">
+                <a:ln>
+                  <a:noFill/>
+                </a:ln>
+                <a:solidFill>
+                  <a:srgbClr val="37474F"/>
+                </a:solidFill>
+                <a:effectLst/>
+                <a:highlight>
+                  <a:srgbClr val="FFFF00"/>
+                </a:highlight>
+                <a:latin typeface="Roboto Mono" panose="00000009000000000000" pitchFamily="49" charset="0"/>
+              </a:rPr>
+              <a:t> </a:t>
+            </a:r>
+            <a:r>
+              <a:rPr kumimoji="0" lang="en-US" altLang="en-US" sz="1600" b="0" i="0" u="none" strike="noStrike" cap="none" normalizeH="0" baseline="0" dirty="0" err="1">
+                <a:ln>
+                  <a:noFill/>
+                </a:ln>
+                <a:solidFill>
+                  <a:srgbClr val="37474F"/>
+                </a:solidFill>
+                <a:effectLst/>
+                <a:highlight>
+                  <a:srgbClr val="FFFF00"/>
+                </a:highlight>
+                <a:latin typeface="Roboto Mono" panose="00000009000000000000" pitchFamily="49" charset="0"/>
+              </a:rPr>
+              <a:t>FastAPI</a:t>
+            </a:r>
+            <a:r>
+              <a:rPr kumimoji="0" lang="en-US" altLang="en-US" sz="1600" b="0" i="0" u="none" strike="noStrike" cap="none" normalizeH="0" baseline="0" dirty="0">
+                <a:ln>
+                  <a:noFill/>
+                </a:ln>
+                <a:solidFill>
+                  <a:srgbClr val="37474F"/>
+                </a:solidFill>
+                <a:effectLst/>
+                <a:highlight>
+                  <a:srgbClr val="FFFF00"/>
+                </a:highlight>
+                <a:latin typeface="Roboto Mono" panose="00000009000000000000" pitchFamily="49" charset="0"/>
+              </a:rPr>
+              <a:t> </a:t>
             </a:r>
           </a:p>
           <a:p>
@@ -8649,7 +8728,39 @@
                 </a:highlight>
                 <a:latin typeface="Roboto Mono" panose="00000009000000000000" pitchFamily="49" charset="0"/>
               </a:rPr>
-              <a:t>app = Flask(__name__) </a:t>
+              <a:t>app = </a:t>
+            </a:r>
+            <a:r>
+              <a:rPr kumimoji="0" lang="en-US" altLang="en-US" sz="1600" b="0" i="0" u="none" strike="noStrike" cap="none" normalizeH="0" baseline="0" dirty="0" err="1">
+                <a:ln>
+                  <a:noFill/>
+                </a:ln>
+                <a:solidFill>
+                  <a:srgbClr val="37474F"/>
+                </a:solidFill>
+                <a:effectLst/>
+                <a:highlight>
+                  <a:srgbClr val="FFFF00"/>
+                </a:highlight>
+                <a:latin typeface="Roboto Mono" panose="00000009000000000000" pitchFamily="49" charset="0"/>
+              </a:rPr>
+              <a:t>FastAPI</a:t>
+            </a:r>
+            <a:r>
+              <a:rPr kumimoji="0" lang="en-US" altLang="en-US" sz="1600" b="0" i="0" u="none" strike="noStrike" cap="none" normalizeH="0" baseline="0" dirty="0">
+                <a:ln>
+                  <a:noFill/>
+                </a:ln>
+                <a:solidFill>
+                  <a:srgbClr val="37474F"/>
+                </a:solidFill>
+                <a:effectLst/>
+                <a:highlight>
+                  <a:srgbClr val="FFFF00"/>
+                </a:highlight>
+                <a:latin typeface="Roboto Mono" panose="00000009000000000000" pitchFamily="49" charset="0"/>
+              </a:rPr>
+              <a:t>() </a:t>
             </a:r>
           </a:p>
           <a:p>
@@ -8707,7 +8818,23 @@
                 </a:highlight>
                 <a:latin typeface="Roboto Mono" panose="00000009000000000000" pitchFamily="49" charset="0"/>
               </a:rPr>
-              <a:t>@app.route(</a:t>
+              <a:t>@</a:t>
+            </a:r>
+            <a:r>
+              <a:rPr kumimoji="0" lang="en-US" altLang="en-US" sz="1600" b="0" i="0" u="none" strike="noStrike" cap="none" normalizeH="0" baseline="0" dirty="0" err="1">
+                <a:ln>
+                  <a:noFill/>
+                </a:ln>
+                <a:solidFill>
+                  <a:srgbClr val="37474F"/>
+                </a:solidFill>
+                <a:effectLst/>
+                <a:highlight>
+                  <a:srgbClr val="FFFF00"/>
+                </a:highlight>
+                <a:latin typeface="Roboto Mono" panose="00000009000000000000" pitchFamily="49" charset="0"/>
+              </a:rPr>
+              <a:t>app.get</a:t>
             </a:r>
             <a:r>
               <a:rPr kumimoji="0" lang="en-US" altLang="en-US" sz="1600" b="0" i="0" u="none" strike="noStrike" cap="none" normalizeH="0" baseline="0" dirty="0">
@@ -8715,7 +8842,7 @@
                   <a:noFill/>
                 </a:ln>
                 <a:solidFill>
-                  <a:srgbClr val="388E3C"/>
+                  <a:srgbClr val="37474F"/>
                 </a:solidFill>
                 <a:effectLst/>
                 <a:highlight>
@@ -8723,7 +8850,55 @@
                 </a:highlight>
                 <a:latin typeface="Roboto Mono" panose="00000009000000000000" pitchFamily="49" charset="0"/>
               </a:rPr>
-              <a:t>"/"</a:t>
+              <a:t>(</a:t>
+            </a:r>
+            <a:r>
+              <a:rPr kumimoji="0" lang="en-US" altLang="en-US" sz="1600" b="0" i="0" u="none" strike="noStrike" cap="none" normalizeH="0" baseline="0" dirty="0">
+                <a:ln>
+                  <a:noFill/>
+                </a:ln>
+                <a:solidFill>
+                  <a:srgbClr val="388E3C"/>
+                </a:solidFill>
+                <a:effectLst/>
+                <a:highlight>
+                  <a:srgbClr val="FFFF00"/>
+                </a:highlight>
+                <a:latin typeface="Roboto Mono" panose="00000009000000000000" pitchFamily="49" charset="0"/>
+              </a:rPr>
+              <a:t>"/</a:t>
+            </a:r>
+            <a:r>
+              <a:rPr kumimoji="0" lang="en-US" altLang="en-US" sz="1600" b="0" i="0" u="none" strike="noStrike" cap="none" normalizeH="0" baseline="0" dirty="0" err="1">
+                <a:ln>
+                  <a:noFill/>
+                </a:ln>
+                <a:solidFill>
+                  <a:srgbClr val="388E3C"/>
+                </a:solidFill>
+                <a:effectLst/>
+                <a:highlight>
+                  <a:srgbClr val="FFFF00"/>
+                </a:highlight>
+                <a:latin typeface="Roboto Mono" panose="00000009000000000000" pitchFamily="49" charset="0"/>
+              </a:rPr>
+              <a:t>hello_world</a:t>
+            </a:r>
+            <a:r>
+              <a:rPr kumimoji="0" lang="en-US" altLang="en-US" sz="1600" b="0" i="0" u="none" strike="noStrike" cap="none" normalizeH="0" baseline="0" dirty="0">
+                <a:ln>
+                  <a:noFill/>
+                </a:ln>
+                <a:solidFill>
+                  <a:srgbClr val="388E3C"/>
+                </a:solidFill>
+                <a:effectLst/>
+                <a:highlight>
+                  <a:srgbClr val="FFFF00"/>
+                </a:highlight>
+                <a:latin typeface="Roboto Mono" panose="00000009000000000000" pitchFamily="49" charset="0"/>
+              </a:rPr>
+              <a:t>"</a:t>
             </a:r>
             <a:r>
               <a:rPr kumimoji="0" lang="en-US" altLang="en-US" sz="1600" b="0" i="0" u="none" strike="noStrike" cap="none" normalizeH="0" baseline="0" dirty="0">
@@ -9427,13 +9602,13 @@
           <p:nvPr/>
         </p:nvPicPr>
         <p:blipFill>
-          <a:blip r:embed="rId2">
+          <a:blip>
             <a:extLst>
               <a:ext uri="{28A0092B-C50C-407E-A947-70E740481C1C}">
                 <a14:useLocalDpi xmlns:a14="http://schemas.microsoft.com/office/drawing/2010/main" val="0"/>
               </a:ext>
               <a:ext uri="{96DAC541-7B7A-43D3-8B79-37D633B846F1}">
-                <asvg:svgBlip xmlns:asvg="http://schemas.microsoft.com/office/drawing/2016/SVG/main" r:embed="rId3"/>
+                <asvg:svgBlip xmlns:asvg="http://schemas.microsoft.com/office/drawing/2016/SVG/main" r:embed="rId2"/>
               </a:ext>
             </a:extLst>
           </a:blip>
@@ -11405,10 +11580,10 @@
           <p:nvPr/>
         </p:nvPicPr>
         <p:blipFill>
-          <a:blip r:embed="rId5">
+          <a:blip>
             <a:extLst>
               <a:ext uri="{96DAC541-7B7A-43D3-8B79-37D633B846F1}">
-                <asvg:svgBlip xmlns:asvg="http://schemas.microsoft.com/office/drawing/2016/SVG/main" r:embed="rId6"/>
+                <asvg:svgBlip xmlns:asvg="http://schemas.microsoft.com/office/drawing/2016/SVG/main" r:embed="rId5"/>
               </a:ext>
             </a:extLst>
           </a:blip>
@@ -12047,13 +12222,13 @@
           <p:nvPr/>
         </p:nvPicPr>
         <p:blipFill>
-          <a:blip r:embed="rId2">
+          <a:blip>
             <a:extLst>
               <a:ext uri="{28A0092B-C50C-407E-A947-70E740481C1C}">
                 <a14:useLocalDpi xmlns:a14="http://schemas.microsoft.com/office/drawing/2010/main" val="0"/>
               </a:ext>
               <a:ext uri="{96DAC541-7B7A-43D3-8B79-37D633B846F1}">
-                <asvg:svgBlip xmlns:asvg="http://schemas.microsoft.com/office/drawing/2016/SVG/main" r:embed="rId3"/>
+                <asvg:svgBlip xmlns:asvg="http://schemas.microsoft.com/office/drawing/2016/SVG/main" r:embed="rId2"/>
               </a:ext>
             </a:extLst>
           </a:blip>
@@ -12086,13 +12261,13 @@
           <p:nvPr/>
         </p:nvPicPr>
         <p:blipFill>
-          <a:blip r:embed="rId4">
+          <a:blip>
             <a:extLst>
               <a:ext uri="{28A0092B-C50C-407E-A947-70E740481C1C}">
                 <a14:useLocalDpi xmlns:a14="http://schemas.microsoft.com/office/drawing/2010/main" val="0"/>
               </a:ext>
               <a:ext uri="{96DAC541-7B7A-43D3-8B79-37D633B846F1}">
-                <asvg:svgBlip xmlns:asvg="http://schemas.microsoft.com/office/drawing/2016/SVG/main" r:embed="rId5"/>
+                <asvg:svgBlip xmlns:asvg="http://schemas.microsoft.com/office/drawing/2016/SVG/main" r:embed="rId3"/>
               </a:ext>
             </a:extLst>
           </a:blip>
@@ -15425,13 +15600,13 @@
           <p:nvPr/>
         </p:nvPicPr>
         <p:blipFill>
-          <a:blip r:embed="rId2">
+          <a:blip>
             <a:extLst>
               <a:ext uri="{28A0092B-C50C-407E-A947-70E740481C1C}">
                 <a14:useLocalDpi xmlns:a14="http://schemas.microsoft.com/office/drawing/2010/main" val="0"/>
               </a:ext>
               <a:ext uri="{96DAC541-7B7A-43D3-8B79-37D633B846F1}">
-                <asvg:svgBlip xmlns:asvg="http://schemas.microsoft.com/office/drawing/2016/SVG/main" r:embed="rId3"/>
+                <asvg:svgBlip xmlns:asvg="http://schemas.microsoft.com/office/drawing/2016/SVG/main" r:embed="rId2"/>
               </a:ext>
             </a:extLst>
           </a:blip>
@@ -15499,13 +15674,13 @@
           <p:nvPr/>
         </p:nvPicPr>
         <p:blipFill>
-          <a:blip r:embed="rId4">
+          <a:blip>
             <a:extLst>
               <a:ext uri="{28A0092B-C50C-407E-A947-70E740481C1C}">
                 <a14:useLocalDpi xmlns:a14="http://schemas.microsoft.com/office/drawing/2010/main" val="0"/>
               </a:ext>
               <a:ext uri="{96DAC541-7B7A-43D3-8B79-37D633B846F1}">
-                <asvg:svgBlip xmlns:asvg="http://schemas.microsoft.com/office/drawing/2016/SVG/main" r:embed="rId5"/>
+                <asvg:svgBlip xmlns:asvg="http://schemas.microsoft.com/office/drawing/2016/SVG/main" r:embed="rId3"/>
               </a:ext>
             </a:extLst>
           </a:blip>
@@ -15573,13 +15748,13 @@
           <p:nvPr/>
         </p:nvPicPr>
         <p:blipFill>
-          <a:blip r:embed="rId4">
+          <a:blip>
             <a:extLst>
               <a:ext uri="{28A0092B-C50C-407E-A947-70E740481C1C}">
                 <a14:useLocalDpi xmlns:a14="http://schemas.microsoft.com/office/drawing/2010/main" val="0"/>
               </a:ext>
               <a:ext uri="{96DAC541-7B7A-43D3-8B79-37D633B846F1}">
-                <asvg:svgBlip xmlns:asvg="http://schemas.microsoft.com/office/drawing/2016/SVG/main" r:embed="rId5"/>
+                <asvg:svgBlip xmlns:asvg="http://schemas.microsoft.com/office/drawing/2016/SVG/main" r:embed="rId3"/>
               </a:ext>
             </a:extLst>
           </a:blip>
@@ -17024,13 +17199,13 @@
           <p:nvPr/>
         </p:nvPicPr>
         <p:blipFill>
-          <a:blip r:embed="rId2">
+          <a:blip>
             <a:extLst>
               <a:ext uri="{28A0092B-C50C-407E-A947-70E740481C1C}">
                 <a14:useLocalDpi xmlns:a14="http://schemas.microsoft.com/office/drawing/2010/main" val="0"/>
               </a:ext>
               <a:ext uri="{96DAC541-7B7A-43D3-8B79-37D633B846F1}">
-                <asvg:svgBlip xmlns:asvg="http://schemas.microsoft.com/office/drawing/2016/SVG/main" r:embed="rId3"/>
+                <asvg:svgBlip xmlns:asvg="http://schemas.microsoft.com/office/drawing/2016/SVG/main" r:embed="rId2"/>
               </a:ext>
             </a:extLst>
           </a:blip>
@@ -17063,13 +17238,13 @@
           <p:nvPr/>
         </p:nvPicPr>
         <p:blipFill>
-          <a:blip r:embed="rId4">
+          <a:blip>
             <a:extLst>
               <a:ext uri="{28A0092B-C50C-407E-A947-70E740481C1C}">
                 <a14:useLocalDpi xmlns:a14="http://schemas.microsoft.com/office/drawing/2010/main" val="0"/>
               </a:ext>
               <a:ext uri="{96DAC541-7B7A-43D3-8B79-37D633B846F1}">
-                <asvg:svgBlip xmlns:asvg="http://schemas.microsoft.com/office/drawing/2016/SVG/main" r:embed="rId5"/>
+                <asvg:svgBlip xmlns:asvg="http://schemas.microsoft.com/office/drawing/2016/SVG/main" r:embed="rId3"/>
               </a:ext>
             </a:extLst>
           </a:blip>
@@ -18699,13 +18874,13 @@
           <p:nvPr/>
         </p:nvPicPr>
         <p:blipFill>
-          <a:blip r:embed="rId2">
+          <a:blip>
             <a:extLst>
               <a:ext uri="{28A0092B-C50C-407E-A947-70E740481C1C}">
                 <a14:useLocalDpi xmlns:a14="http://schemas.microsoft.com/office/drawing/2010/main" val="0"/>
               </a:ext>
               <a:ext uri="{96DAC541-7B7A-43D3-8B79-37D633B846F1}">
-                <asvg:svgBlip xmlns:asvg="http://schemas.microsoft.com/office/drawing/2016/SVG/main" r:embed="rId3"/>
+                <asvg:svgBlip xmlns:asvg="http://schemas.microsoft.com/office/drawing/2016/SVG/main" r:embed="rId2"/>
               </a:ext>
             </a:extLst>
           </a:blip>
@@ -18738,13 +18913,13 @@
           <p:nvPr/>
         </p:nvPicPr>
         <p:blipFill>
-          <a:blip r:embed="rId4">
+          <a:blip>
             <a:extLst>
               <a:ext uri="{28A0092B-C50C-407E-A947-70E740481C1C}">
                 <a14:useLocalDpi xmlns:a14="http://schemas.microsoft.com/office/drawing/2010/main" val="0"/>
               </a:ext>
               <a:ext uri="{96DAC541-7B7A-43D3-8B79-37D633B846F1}">
-                <asvg:svgBlip xmlns:asvg="http://schemas.microsoft.com/office/drawing/2016/SVG/main" r:embed="rId5"/>
+                <asvg:svgBlip xmlns:asvg="http://schemas.microsoft.com/office/drawing/2016/SVG/main" r:embed="rId3"/>
               </a:ext>
             </a:extLst>
           </a:blip>
@@ -20432,7 +20607,7 @@
           <p:cNvPr id="2" name="Title 1">
             <a:extLst>
               <a:ext uri="{FF2B5EF4-FFF2-40B4-BE49-F238E27FC236}">
-                <a16:creationId xmlns:a16="http://schemas.microsoft.com/office/drawing/2014/main" id="{EF72CA72-DA98-6FE0-2F18-D95CF320C69F}"/>
+                <a16:creationId xmlns:a16="http://schemas.microsoft.com/office/drawing/2014/main" id="{0E2EFFAF-1A2D-E0FD-E989-BCA4252319F6}"/>
               </a:ext>
             </a:extLst>
           </p:cNvPr>
@@ -20449,6 +20624,408 @@
           <a:lstStyle/>
           <a:p>
             <a:r>
+              <a:rPr lang="en-US" dirty="0" err="1"/>
+              <a:t>cURL</a:t>
+            </a:r>
+            <a:r>
+              <a:rPr lang="en-US" dirty="0"/>
+              <a:t> is an extremely versatile tool</a:t>
+            </a:r>
+          </a:p>
+        </p:txBody>
+      </p:sp>
+      <p:sp>
+        <p:nvSpPr>
+          <p:cNvPr id="3" name="TextBox 2">
+            <a:extLst>
+              <a:ext uri="{FF2B5EF4-FFF2-40B4-BE49-F238E27FC236}">
+                <a16:creationId xmlns:a16="http://schemas.microsoft.com/office/drawing/2014/main" id="{661FB449-0556-92D6-BCC1-5D83D3BD292D}"/>
+              </a:ext>
+            </a:extLst>
+          </p:cNvPr>
+          <p:cNvSpPr txBox="1"/>
+          <p:nvPr/>
+        </p:nvSpPr>
+        <p:spPr>
+          <a:xfrm>
+            <a:off x="575935" y="2335575"/>
+            <a:ext cx="9777035" cy="3170099"/>
+          </a:xfrm>
+          <a:prstGeom prst="rect">
+            <a:avLst/>
+          </a:prstGeom>
+          <a:noFill/>
+        </p:spPr>
+        <p:txBody>
+          <a:bodyPr wrap="none" rtlCol="0">
+            <a:spAutoFit/>
+          </a:bodyPr>
+          <a:lstStyle/>
+          <a:p>
+            <a:r>
+              <a:rPr lang="en-US" sz="2000" dirty="0">
+                <a:solidFill>
+                  <a:schemeClr val="tx1">
+                    <a:lumMod val="75000"/>
+                    <a:lumOff val="25000"/>
+                  </a:schemeClr>
+                </a:solidFill>
+                <a:latin typeface="Georgia" panose="02040502050405020303" pitchFamily="18" charset="0"/>
+              </a:rPr>
+              <a:t>Normal </a:t>
+            </a:r>
+            <a:r>
+              <a:rPr lang="en-US" sz="2000" dirty="0">
+                <a:solidFill>
+                  <a:schemeClr val="tx1">
+                    <a:lumMod val="75000"/>
+                    <a:lumOff val="25000"/>
+                  </a:schemeClr>
+                </a:solidFill>
+                <a:latin typeface="Consolas" panose="020B0609020204030204" pitchFamily="49" charset="0"/>
+              </a:rPr>
+              <a:t>GET</a:t>
+            </a:r>
+            <a:r>
+              <a:rPr lang="en-US" sz="2000" dirty="0">
+                <a:solidFill>
+                  <a:schemeClr val="tx1">
+                    <a:lumMod val="75000"/>
+                    <a:lumOff val="25000"/>
+                  </a:schemeClr>
+                </a:solidFill>
+                <a:latin typeface="Georgia" panose="02040502050405020303" pitchFamily="18" charset="0"/>
+              </a:rPr>
+              <a:t> request</a:t>
+            </a:r>
+          </a:p>
+          <a:p>
+            <a:r>
+              <a:rPr lang="en-US" sz="2000" dirty="0">
+                <a:solidFill>
+                  <a:schemeClr val="tx1">
+                    <a:lumMod val="75000"/>
+                    <a:lumOff val="25000"/>
+                  </a:schemeClr>
+                </a:solidFill>
+                <a:latin typeface="Consolas" panose="020B0609020204030204" pitchFamily="49" charset="0"/>
+              </a:rPr>
+              <a:t>curl </a:t>
+            </a:r>
+            <a:r>
+              <a:rPr lang="en-US" sz="2000" dirty="0">
+                <a:solidFill>
+                  <a:schemeClr val="tx1">
+                    <a:lumMod val="75000"/>
+                    <a:lumOff val="25000"/>
+                  </a:schemeClr>
+                </a:solidFill>
+                <a:latin typeface="Consolas" panose="020B0609020204030204" pitchFamily="49" charset="0"/>
+                <a:hlinkClick r:id="rId2">
+                  <a:extLst>
+                    <a:ext uri="{A12FA001-AC4F-418D-AE19-62706E023703}">
+                      <ahyp:hlinkClr xmlns:ahyp="http://schemas.microsoft.com/office/drawing/2018/hyperlinkcolor" val="tx"/>
+                    </a:ext>
+                  </a:extLst>
+                </a:hlinkClick>
+              </a:rPr>
+              <a:t>http://somewebsite.com/some_resource</a:t>
+            </a:r>
+            <a:endParaRPr lang="en-US" sz="2000" dirty="0">
+              <a:solidFill>
+                <a:schemeClr val="tx1">
+                  <a:lumMod val="75000"/>
+                  <a:lumOff val="25000"/>
+                </a:schemeClr>
+              </a:solidFill>
+              <a:latin typeface="Consolas" panose="020B0609020204030204" pitchFamily="49" charset="0"/>
+            </a:endParaRPr>
+          </a:p>
+          <a:p>
+            <a:endParaRPr lang="en-US" sz="2000" dirty="0">
+              <a:solidFill>
+                <a:schemeClr val="tx1">
+                  <a:lumMod val="75000"/>
+                  <a:lumOff val="25000"/>
+                </a:schemeClr>
+              </a:solidFill>
+              <a:latin typeface="Georgia" panose="02040502050405020303" pitchFamily="18" charset="0"/>
+            </a:endParaRPr>
+          </a:p>
+          <a:p>
+            <a:endParaRPr lang="en-US" sz="2000" dirty="0">
+              <a:solidFill>
+                <a:schemeClr val="tx1">
+                  <a:lumMod val="75000"/>
+                  <a:lumOff val="25000"/>
+                </a:schemeClr>
+              </a:solidFill>
+              <a:latin typeface="Consolas" panose="020B0609020204030204" pitchFamily="49" charset="0"/>
+            </a:endParaRPr>
+          </a:p>
+          <a:p>
+            <a:r>
+              <a:rPr lang="en-US" sz="2000" dirty="0">
+                <a:solidFill>
+                  <a:schemeClr val="tx1">
+                    <a:lumMod val="75000"/>
+                    <a:lumOff val="25000"/>
+                  </a:schemeClr>
+                </a:solidFill>
+                <a:latin typeface="Consolas" panose="020B0609020204030204" pitchFamily="49" charset="0"/>
+              </a:rPr>
+              <a:t>POST</a:t>
+            </a:r>
+            <a:r>
+              <a:rPr lang="en-US" sz="2000" dirty="0">
+                <a:solidFill>
+                  <a:schemeClr val="tx1">
+                    <a:lumMod val="75000"/>
+                    <a:lumOff val="25000"/>
+                  </a:schemeClr>
+                </a:solidFill>
+                <a:latin typeface="Georgia" panose="02040502050405020303" pitchFamily="18" charset="0"/>
+              </a:rPr>
+              <a:t> request with a JSON payload</a:t>
+            </a:r>
+          </a:p>
+          <a:p>
+            <a:r>
+              <a:rPr lang="en-US" sz="2000" dirty="0">
+                <a:solidFill>
+                  <a:schemeClr val="tx1">
+                    <a:lumMod val="75000"/>
+                    <a:lumOff val="25000"/>
+                  </a:schemeClr>
+                </a:solidFill>
+                <a:latin typeface="Consolas" panose="020B0609020204030204" pitchFamily="49" charset="0"/>
+              </a:rPr>
+              <a:t>curl –X POST \</a:t>
+            </a:r>
+          </a:p>
+          <a:p>
+            <a:r>
+              <a:rPr lang="en-US" sz="2000" dirty="0">
+                <a:solidFill>
+                  <a:schemeClr val="tx1">
+                    <a:lumMod val="75000"/>
+                    <a:lumOff val="25000"/>
+                  </a:schemeClr>
+                </a:solidFill>
+                <a:latin typeface="Consolas" panose="020B0609020204030204" pitchFamily="49" charset="0"/>
+              </a:rPr>
+              <a:t>  –H “Content-Type: application/</a:t>
+            </a:r>
+            <a:r>
+              <a:rPr lang="en-US" sz="2000" dirty="0" err="1">
+                <a:solidFill>
+                  <a:schemeClr val="tx1">
+                    <a:lumMod val="75000"/>
+                    <a:lumOff val="25000"/>
+                  </a:schemeClr>
+                </a:solidFill>
+                <a:latin typeface="Consolas" panose="020B0609020204030204" pitchFamily="49" charset="0"/>
+              </a:rPr>
+              <a:t>json</a:t>
+            </a:r>
+            <a:r>
+              <a:rPr lang="en-US" sz="2000" dirty="0">
+                <a:solidFill>
+                  <a:schemeClr val="tx1">
+                    <a:lumMod val="75000"/>
+                    <a:lumOff val="25000"/>
+                  </a:schemeClr>
+                </a:solidFill>
+                <a:latin typeface="Consolas" panose="020B0609020204030204" pitchFamily="49" charset="0"/>
+              </a:rPr>
+              <a:t>” \</a:t>
+            </a:r>
+          </a:p>
+          <a:p>
+            <a:r>
+              <a:rPr lang="en-US" sz="2000" dirty="0">
+                <a:solidFill>
+                  <a:schemeClr val="tx1">
+                    <a:lumMod val="75000"/>
+                    <a:lumOff val="25000"/>
+                  </a:schemeClr>
+                </a:solidFill>
+                <a:latin typeface="Consolas" panose="020B0609020204030204" pitchFamily="49" charset="0"/>
+              </a:rPr>
+              <a:t>  –d “{param1:val, param2:val}” </a:t>
+            </a:r>
+            <a:r>
+              <a:rPr lang="en-US" sz="2000" dirty="0">
+                <a:solidFill>
+                  <a:schemeClr val="tx1">
+                    <a:lumMod val="75000"/>
+                    <a:lumOff val="25000"/>
+                  </a:schemeClr>
+                </a:solidFill>
+                <a:latin typeface="Consolas" panose="020B0609020204030204" pitchFamily="49" charset="0"/>
+                <a:hlinkClick r:id="rId2">
+                  <a:extLst>
+                    <a:ext uri="{A12FA001-AC4F-418D-AE19-62706E023703}">
+                      <ahyp:hlinkClr xmlns:ahyp="http://schemas.microsoft.com/office/drawing/2018/hyperlinkcolor" val="tx"/>
+                    </a:ext>
+                  </a:extLst>
+                </a:hlinkClick>
+              </a:rPr>
+              <a:t>http://somewebsite.com/some_resource</a:t>
+            </a:r>
+            <a:endParaRPr lang="en-US" sz="2000" dirty="0">
+              <a:solidFill>
+                <a:schemeClr val="tx1">
+                  <a:lumMod val="75000"/>
+                  <a:lumOff val="25000"/>
+                </a:schemeClr>
+              </a:solidFill>
+              <a:latin typeface="Consolas" panose="020B0609020204030204" pitchFamily="49" charset="0"/>
+            </a:endParaRPr>
+          </a:p>
+          <a:p>
+            <a:endParaRPr lang="en-US" sz="2000" dirty="0">
+              <a:solidFill>
+                <a:schemeClr val="tx1">
+                  <a:lumMod val="75000"/>
+                  <a:lumOff val="25000"/>
+                </a:schemeClr>
+              </a:solidFill>
+              <a:latin typeface="Georgia" panose="02040502050405020303" pitchFamily="18" charset="0"/>
+            </a:endParaRPr>
+          </a:p>
+          <a:p>
+            <a:endParaRPr lang="en-US" sz="2000" dirty="0">
+              <a:solidFill>
+                <a:schemeClr val="tx1">
+                  <a:lumMod val="75000"/>
+                  <a:lumOff val="25000"/>
+                </a:schemeClr>
+              </a:solidFill>
+              <a:latin typeface="Georgia" panose="02040502050405020303" pitchFamily="18" charset="0"/>
+            </a:endParaRPr>
+          </a:p>
+        </p:txBody>
+      </p:sp>
+      <p:sp>
+        <p:nvSpPr>
+          <p:cNvPr id="5" name="TextBox 4">
+            <a:extLst>
+              <a:ext uri="{FF2B5EF4-FFF2-40B4-BE49-F238E27FC236}">
+                <a16:creationId xmlns:a16="http://schemas.microsoft.com/office/drawing/2014/main" id="{918F810C-5AAB-A682-E387-84BC7DB004FD}"/>
+              </a:ext>
+            </a:extLst>
+          </p:cNvPr>
+          <p:cNvSpPr txBox="1"/>
+          <p:nvPr/>
+        </p:nvSpPr>
+        <p:spPr>
+          <a:xfrm>
+            <a:off x="575935" y="6027450"/>
+            <a:ext cx="10172930" cy="276999"/>
+          </a:xfrm>
+          <a:prstGeom prst="rect">
+            <a:avLst/>
+          </a:prstGeom>
+          <a:noFill/>
+        </p:spPr>
+        <p:txBody>
+          <a:bodyPr wrap="square">
+            <a:spAutoFit/>
+          </a:bodyPr>
+          <a:lstStyle/>
+          <a:p>
+            <a:r>
+              <a:rPr lang="en-US" sz="1200" b="1" dirty="0">
+                <a:latin typeface="Consolas" panose="020B0609020204030204" pitchFamily="49" charset="0"/>
+              </a:rPr>
+              <a:t>Warning</a:t>
+            </a:r>
+            <a:r>
+              <a:rPr lang="en-US" sz="1200" dirty="0">
+                <a:latin typeface="Consolas" panose="020B0609020204030204" pitchFamily="49" charset="0"/>
+              </a:rPr>
+              <a:t>: windows and mac/</a:t>
+            </a:r>
+            <a:r>
+              <a:rPr lang="en-US" sz="1200" dirty="0" err="1">
+                <a:latin typeface="Consolas" panose="020B0609020204030204" pitchFamily="49" charset="0"/>
+              </a:rPr>
+              <a:t>linux</a:t>
+            </a:r>
+            <a:r>
+              <a:rPr lang="en-US" sz="1200" dirty="0">
+                <a:latin typeface="Consolas" panose="020B0609020204030204" pitchFamily="49" charset="0"/>
+              </a:rPr>
+              <a:t> have tools called </a:t>
+            </a:r>
+            <a:r>
+              <a:rPr lang="en-US" sz="1200" i="1" dirty="0">
+                <a:latin typeface="Consolas" panose="020B0609020204030204" pitchFamily="49" charset="0"/>
+              </a:rPr>
+              <a:t>curl</a:t>
+            </a:r>
+            <a:r>
+              <a:rPr lang="en-US" sz="1200" dirty="0">
+                <a:latin typeface="Consolas" panose="020B0609020204030204" pitchFamily="49" charset="0"/>
+              </a:rPr>
+              <a:t>, but they seem to be slightly different</a:t>
+            </a:r>
+          </a:p>
+        </p:txBody>
+      </p:sp>
+    </p:spTree>
+    <p:extLst>
+      <p:ext uri="{BB962C8B-B14F-4D97-AF65-F5344CB8AC3E}">
+        <p14:creationId xmlns:p14="http://schemas.microsoft.com/office/powerpoint/2010/main" val="923356200"/>
+      </p:ext>
+    </p:extLst>
+  </p:cSld>
+  <p:clrMapOvr>
+    <a:masterClrMapping/>
+  </p:clrMapOvr>
+</p:sld>
+</file>
+
+<file path=ppt/slides/slide33.xml><?xml version="1.0" encoding="utf-8"?>
+<p:sld xmlns:a="http://schemas.openxmlformats.org/drawingml/2006/main" xmlns:r="http://schemas.openxmlformats.org/officeDocument/2006/relationships" xmlns:p="http://schemas.openxmlformats.org/presentationml/2006/main">
+  <p:cSld>
+    <p:spTree>
+      <p:nvGrpSpPr>
+        <p:cNvPr id="1" name=""/>
+        <p:cNvGrpSpPr/>
+        <p:nvPr/>
+      </p:nvGrpSpPr>
+      <p:grpSpPr>
+        <a:xfrm>
+          <a:off x="0" y="0"/>
+          <a:ext cx="0" cy="0"/>
+          <a:chOff x="0" y="0"/>
+          <a:chExt cx="0" cy="0"/>
+        </a:xfrm>
+      </p:grpSpPr>
+      <p:sp>
+        <p:nvSpPr>
+          <p:cNvPr id="2" name="Title 1">
+            <a:extLst>
+              <a:ext uri="{FF2B5EF4-FFF2-40B4-BE49-F238E27FC236}">
+                <a16:creationId xmlns:a16="http://schemas.microsoft.com/office/drawing/2014/main" id="{EF72CA72-DA98-6FE0-2F18-D95CF320C69F}"/>
+              </a:ext>
+            </a:extLst>
+          </p:cNvPr>
+          <p:cNvSpPr>
+            <a:spLocks noGrp="1"/>
+          </p:cNvSpPr>
+          <p:nvPr>
+            <p:ph type="title"/>
+          </p:nvPr>
+        </p:nvSpPr>
+        <p:spPr/>
+        <p:txBody>
+          <a:bodyPr/>
+          <a:lstStyle/>
+          <a:p>
+            <a:r>
               <a:rPr lang="en-US" dirty="0"/>
               <a:t>Practically every language has libraries for writing http clients and servers</a:t>
             </a:r>
@@ -20470,7 +21047,7 @@
         <p:spPr>
           <a:xfrm>
             <a:off x="980502" y="2280492"/>
-            <a:ext cx="4847422" cy="2308324"/>
+            <a:ext cx="4847422" cy="1477328"/>
           </a:xfrm>
           <a:prstGeom prst="rect">
             <a:avLst/>
@@ -20517,44 +21094,6 @@
             <a:endParaRPr lang="en-US" dirty="0">
               <a:latin typeface="Consolas" panose="020B0609020204030204" pitchFamily="49" charset="0"/>
             </a:endParaRPr>
-          </a:p>
-          <a:p>
-            <a:r>
-              <a:rPr lang="en-US" b="1" dirty="0">
-                <a:latin typeface="Consolas" panose="020B0609020204030204" pitchFamily="49" charset="0"/>
-              </a:rPr>
-              <a:t>Warning</a:t>
-            </a:r>
-            <a:r>
-              <a:rPr lang="en-US" dirty="0">
-                <a:latin typeface="Consolas" panose="020B0609020204030204" pitchFamily="49" charset="0"/>
-              </a:rPr>
-              <a:t>: windows and mac/</a:t>
-            </a:r>
-            <a:r>
-              <a:rPr lang="en-US" dirty="0" err="1">
-                <a:latin typeface="Consolas" panose="020B0609020204030204" pitchFamily="49" charset="0"/>
-              </a:rPr>
-              <a:t>linux</a:t>
-            </a:r>
-            <a:r>
-              <a:rPr lang="en-US" dirty="0">
-                <a:latin typeface="Consolas" panose="020B0609020204030204" pitchFamily="49" charset="0"/>
-              </a:rPr>
-              <a:t> have tools called </a:t>
-            </a:r>
-            <a:r>
-              <a:rPr lang="en-US" i="1" dirty="0">
-                <a:latin typeface="Consolas" panose="020B0609020204030204" pitchFamily="49" charset="0"/>
-              </a:rPr>
-              <a:t>curl</a:t>
-            </a:r>
-            <a:r>
-              <a:rPr lang="en-US" dirty="0">
-                <a:latin typeface="Consolas" panose="020B0609020204030204" pitchFamily="49" charset="0"/>
-              </a:rPr>
-              <a:t>, but they seem to be slightly different</a:t>
-            </a:r>
           </a:p>
         </p:txBody>
       </p:sp>
@@ -20608,7 +21147,7 @@
 </p:sld>
 </file>
 
-<file path=ppt/slides/slide33.xml><?xml version="1.0" encoding="utf-8"?>
+<file path=ppt/slides/slide34.xml><?xml version="1.0" encoding="utf-8"?>
 <p:sld xmlns:a="http://schemas.openxmlformats.org/drawingml/2006/main" xmlns:r="http://schemas.openxmlformats.org/officeDocument/2006/relationships" xmlns:p="http://schemas.openxmlformats.org/presentationml/2006/main">
   <p:cSld>
     <p:spTree>
@@ -21116,408 +21655,6 @@
     <p:extLst>
       <p:ext uri="{BB962C8B-B14F-4D97-AF65-F5344CB8AC3E}">
         <p14:creationId xmlns:p14="http://schemas.microsoft.com/office/powerpoint/2010/main" val="4226127547"/>
-      </p:ext>
-    </p:extLst>
-  </p:cSld>
-  <p:clrMapOvr>
-    <a:masterClrMapping/>
-  </p:clrMapOvr>
-</p:sld>
-</file>
-
-<file path=ppt/slides/slide34.xml><?xml version="1.0" encoding="utf-8"?>
-<p:sld xmlns:a="http://schemas.openxmlformats.org/drawingml/2006/main" xmlns:r="http://schemas.openxmlformats.org/officeDocument/2006/relationships" xmlns:p="http://schemas.openxmlformats.org/presentationml/2006/main">
-  <p:cSld>
-    <p:spTree>
-      <p:nvGrpSpPr>
-        <p:cNvPr id="1" name=""/>
-        <p:cNvGrpSpPr/>
-        <p:nvPr/>
-      </p:nvGrpSpPr>
-      <p:grpSpPr>
-        <a:xfrm>
-          <a:off x="0" y="0"/>
-          <a:ext cx="0" cy="0"/>
-          <a:chOff x="0" y="0"/>
-          <a:chExt cx="0" cy="0"/>
-        </a:xfrm>
-      </p:grpSpPr>
-      <p:sp>
-        <p:nvSpPr>
-          <p:cNvPr id="2" name="Title 1">
-            <a:extLst>
-              <a:ext uri="{FF2B5EF4-FFF2-40B4-BE49-F238E27FC236}">
-                <a16:creationId xmlns:a16="http://schemas.microsoft.com/office/drawing/2014/main" id="{0E2EFFAF-1A2D-E0FD-E989-BCA4252319F6}"/>
-              </a:ext>
-            </a:extLst>
-          </p:cNvPr>
-          <p:cNvSpPr>
-            <a:spLocks noGrp="1"/>
-          </p:cNvSpPr>
-          <p:nvPr>
-            <p:ph type="title"/>
-          </p:nvPr>
-        </p:nvSpPr>
-        <p:spPr/>
-        <p:txBody>
-          <a:bodyPr/>
-          <a:lstStyle/>
-          <a:p>
-            <a:r>
-              <a:rPr lang="en-US" dirty="0" err="1"/>
-              <a:t>cURL</a:t>
-            </a:r>
-            <a:r>
-              <a:rPr lang="en-US" dirty="0"/>
-              <a:t> is an extremely versatile tool</a:t>
-            </a:r>
-          </a:p>
-        </p:txBody>
-      </p:sp>
-      <p:sp>
-        <p:nvSpPr>
-          <p:cNvPr id="3" name="TextBox 2">
-            <a:extLst>
-              <a:ext uri="{FF2B5EF4-FFF2-40B4-BE49-F238E27FC236}">
-                <a16:creationId xmlns:a16="http://schemas.microsoft.com/office/drawing/2014/main" id="{661FB449-0556-92D6-BCC1-5D83D3BD292D}"/>
-              </a:ext>
-            </a:extLst>
-          </p:cNvPr>
-          <p:cNvSpPr txBox="1"/>
-          <p:nvPr/>
-        </p:nvSpPr>
-        <p:spPr>
-          <a:xfrm>
-            <a:off x="575935" y="2335575"/>
-            <a:ext cx="9777035" cy="3170099"/>
-          </a:xfrm>
-          <a:prstGeom prst="rect">
-            <a:avLst/>
-          </a:prstGeom>
-          <a:noFill/>
-        </p:spPr>
-        <p:txBody>
-          <a:bodyPr wrap="none" rtlCol="0">
-            <a:spAutoFit/>
-          </a:bodyPr>
-          <a:lstStyle/>
-          <a:p>
-            <a:r>
-              <a:rPr lang="en-US" sz="2000" dirty="0">
-                <a:solidFill>
-                  <a:schemeClr val="tx1">
-                    <a:lumMod val="75000"/>
-                    <a:lumOff val="25000"/>
-                  </a:schemeClr>
-                </a:solidFill>
-                <a:latin typeface="Georgia" panose="02040502050405020303" pitchFamily="18" charset="0"/>
-              </a:rPr>
-              <a:t>Normal </a:t>
-            </a:r>
-            <a:r>
-              <a:rPr lang="en-US" sz="2000" dirty="0">
-                <a:solidFill>
-                  <a:schemeClr val="tx1">
-                    <a:lumMod val="75000"/>
-                    <a:lumOff val="25000"/>
-                  </a:schemeClr>
-                </a:solidFill>
-                <a:latin typeface="Consolas" panose="020B0609020204030204" pitchFamily="49" charset="0"/>
-              </a:rPr>
-              <a:t>GET</a:t>
-            </a:r>
-            <a:r>
-              <a:rPr lang="en-US" sz="2000" dirty="0">
-                <a:solidFill>
-                  <a:schemeClr val="tx1">
-                    <a:lumMod val="75000"/>
-                    <a:lumOff val="25000"/>
-                  </a:schemeClr>
-                </a:solidFill>
-                <a:latin typeface="Georgia" panose="02040502050405020303" pitchFamily="18" charset="0"/>
-              </a:rPr>
-              <a:t> request</a:t>
-            </a:r>
-          </a:p>
-          <a:p>
-            <a:r>
-              <a:rPr lang="en-US" sz="2000" dirty="0">
-                <a:solidFill>
-                  <a:schemeClr val="tx1">
-                    <a:lumMod val="75000"/>
-                    <a:lumOff val="25000"/>
-                  </a:schemeClr>
-                </a:solidFill>
-                <a:latin typeface="Consolas" panose="020B0609020204030204" pitchFamily="49" charset="0"/>
-              </a:rPr>
-              <a:t>curl </a:t>
-            </a:r>
-            <a:r>
-              <a:rPr lang="en-US" sz="2000" dirty="0">
-                <a:solidFill>
-                  <a:schemeClr val="tx1">
-                    <a:lumMod val="75000"/>
-                    <a:lumOff val="25000"/>
-                  </a:schemeClr>
-                </a:solidFill>
-                <a:latin typeface="Consolas" panose="020B0609020204030204" pitchFamily="49" charset="0"/>
-                <a:hlinkClick r:id="rId2">
-                  <a:extLst>
-                    <a:ext uri="{A12FA001-AC4F-418D-AE19-62706E023703}">
-                      <ahyp:hlinkClr xmlns:ahyp="http://schemas.microsoft.com/office/drawing/2018/hyperlinkcolor" val="tx"/>
-                    </a:ext>
-                  </a:extLst>
-                </a:hlinkClick>
-              </a:rPr>
-              <a:t>http://somewebsite.com/some_resource</a:t>
-            </a:r>
-            <a:endParaRPr lang="en-US" sz="2000" dirty="0">
-              <a:solidFill>
-                <a:schemeClr val="tx1">
-                  <a:lumMod val="75000"/>
-                  <a:lumOff val="25000"/>
-                </a:schemeClr>
-              </a:solidFill>
-              <a:latin typeface="Consolas" panose="020B0609020204030204" pitchFamily="49" charset="0"/>
-            </a:endParaRPr>
-          </a:p>
-          <a:p>
-            <a:endParaRPr lang="en-US" sz="2000" dirty="0">
-              <a:solidFill>
-                <a:schemeClr val="tx1">
-                  <a:lumMod val="75000"/>
-                  <a:lumOff val="25000"/>
-                </a:schemeClr>
-              </a:solidFill>
-              <a:latin typeface="Georgia" panose="02040502050405020303" pitchFamily="18" charset="0"/>
-            </a:endParaRPr>
-          </a:p>
-          <a:p>
-            <a:endParaRPr lang="en-US" sz="2000" dirty="0">
-              <a:solidFill>
-                <a:schemeClr val="tx1">
-                  <a:lumMod val="75000"/>
-                  <a:lumOff val="25000"/>
-                </a:schemeClr>
-              </a:solidFill>
-              <a:latin typeface="Consolas" panose="020B0609020204030204" pitchFamily="49" charset="0"/>
-            </a:endParaRPr>
-          </a:p>
-          <a:p>
-            <a:r>
-              <a:rPr lang="en-US" sz="2000" dirty="0">
-                <a:solidFill>
-                  <a:schemeClr val="tx1">
-                    <a:lumMod val="75000"/>
-                    <a:lumOff val="25000"/>
-                  </a:schemeClr>
-                </a:solidFill>
-                <a:latin typeface="Consolas" panose="020B0609020204030204" pitchFamily="49" charset="0"/>
-              </a:rPr>
-              <a:t>POST</a:t>
-            </a:r>
-            <a:r>
-              <a:rPr lang="en-US" sz="2000" dirty="0">
-                <a:solidFill>
-                  <a:schemeClr val="tx1">
-                    <a:lumMod val="75000"/>
-                    <a:lumOff val="25000"/>
-                  </a:schemeClr>
-                </a:solidFill>
-                <a:latin typeface="Georgia" panose="02040502050405020303" pitchFamily="18" charset="0"/>
-              </a:rPr>
-              <a:t> request with a JSON payload</a:t>
-            </a:r>
-          </a:p>
-          <a:p>
-            <a:r>
-              <a:rPr lang="en-US" sz="2000" dirty="0">
-                <a:solidFill>
-                  <a:schemeClr val="tx1">
-                    <a:lumMod val="75000"/>
-                    <a:lumOff val="25000"/>
-                  </a:schemeClr>
-                </a:solidFill>
-                <a:latin typeface="Consolas" panose="020B0609020204030204" pitchFamily="49" charset="0"/>
-              </a:rPr>
-              <a:t>curl –X POST \</a:t>
-            </a:r>
-          </a:p>
-          <a:p>
-            <a:r>
-              <a:rPr lang="en-US" sz="2000" dirty="0">
-                <a:solidFill>
-                  <a:schemeClr val="tx1">
-                    <a:lumMod val="75000"/>
-                    <a:lumOff val="25000"/>
-                  </a:schemeClr>
-                </a:solidFill>
-                <a:latin typeface="Consolas" panose="020B0609020204030204" pitchFamily="49" charset="0"/>
-              </a:rPr>
-              <a:t>  –H “Content-Type: application/</a:t>
-            </a:r>
-            <a:r>
-              <a:rPr lang="en-US" sz="2000" dirty="0" err="1">
-                <a:solidFill>
-                  <a:schemeClr val="tx1">
-                    <a:lumMod val="75000"/>
-                    <a:lumOff val="25000"/>
-                  </a:schemeClr>
-                </a:solidFill>
-                <a:latin typeface="Consolas" panose="020B0609020204030204" pitchFamily="49" charset="0"/>
-              </a:rPr>
-              <a:t>json</a:t>
-            </a:r>
-            <a:r>
-              <a:rPr lang="en-US" sz="2000" dirty="0">
-                <a:solidFill>
-                  <a:schemeClr val="tx1">
-                    <a:lumMod val="75000"/>
-                    <a:lumOff val="25000"/>
-                  </a:schemeClr>
-                </a:solidFill>
-                <a:latin typeface="Consolas" panose="020B0609020204030204" pitchFamily="49" charset="0"/>
-              </a:rPr>
-              <a:t>” \</a:t>
-            </a:r>
-          </a:p>
-          <a:p>
-            <a:r>
-              <a:rPr lang="en-US" sz="2000" dirty="0">
-                <a:solidFill>
-                  <a:schemeClr val="tx1">
-                    <a:lumMod val="75000"/>
-                    <a:lumOff val="25000"/>
-                  </a:schemeClr>
-                </a:solidFill>
-                <a:latin typeface="Consolas" panose="020B0609020204030204" pitchFamily="49" charset="0"/>
-              </a:rPr>
-              <a:t>  –d “{param1:val, param2:val}” </a:t>
-            </a:r>
-            <a:r>
-              <a:rPr lang="en-US" sz="2000" dirty="0">
-                <a:solidFill>
-                  <a:schemeClr val="tx1">
-                    <a:lumMod val="75000"/>
-                    <a:lumOff val="25000"/>
-                  </a:schemeClr>
-                </a:solidFill>
-                <a:latin typeface="Consolas" panose="020B0609020204030204" pitchFamily="49" charset="0"/>
-                <a:hlinkClick r:id="rId2">
-                  <a:extLst>
-                    <a:ext uri="{A12FA001-AC4F-418D-AE19-62706E023703}">
-                      <ahyp:hlinkClr xmlns:ahyp="http://schemas.microsoft.com/office/drawing/2018/hyperlinkcolor" val="tx"/>
-                    </a:ext>
-                  </a:extLst>
-                </a:hlinkClick>
-              </a:rPr>
-              <a:t>http://somewebsite.com/some_resource</a:t>
-            </a:r>
-            <a:endParaRPr lang="en-US" sz="2000" dirty="0">
-              <a:solidFill>
-                <a:schemeClr val="tx1">
-                  <a:lumMod val="75000"/>
-                  <a:lumOff val="25000"/>
-                </a:schemeClr>
-              </a:solidFill>
-              <a:latin typeface="Consolas" panose="020B0609020204030204" pitchFamily="49" charset="0"/>
-            </a:endParaRPr>
-          </a:p>
-          <a:p>
-            <a:endParaRPr lang="en-US" sz="2000" dirty="0">
-              <a:solidFill>
-                <a:schemeClr val="tx1">
-                  <a:lumMod val="75000"/>
-                  <a:lumOff val="25000"/>
-                </a:schemeClr>
-              </a:solidFill>
-              <a:latin typeface="Georgia" panose="02040502050405020303" pitchFamily="18" charset="0"/>
-            </a:endParaRPr>
-          </a:p>
-          <a:p>
-            <a:endParaRPr lang="en-US" sz="2000" dirty="0">
-              <a:solidFill>
-                <a:schemeClr val="tx1">
-                  <a:lumMod val="75000"/>
-                  <a:lumOff val="25000"/>
-                </a:schemeClr>
-              </a:solidFill>
-              <a:latin typeface="Georgia" panose="02040502050405020303" pitchFamily="18" charset="0"/>
-            </a:endParaRPr>
-          </a:p>
-        </p:txBody>
-      </p:sp>
-      <p:sp>
-        <p:nvSpPr>
-          <p:cNvPr id="5" name="TextBox 4">
-            <a:extLst>
-              <a:ext uri="{FF2B5EF4-FFF2-40B4-BE49-F238E27FC236}">
-                <a16:creationId xmlns:a16="http://schemas.microsoft.com/office/drawing/2014/main" id="{918F810C-5AAB-A682-E387-84BC7DB004FD}"/>
-              </a:ext>
-            </a:extLst>
-          </p:cNvPr>
-          <p:cNvSpPr txBox="1"/>
-          <p:nvPr/>
-        </p:nvSpPr>
-        <p:spPr>
-          <a:xfrm>
-            <a:off x="575935" y="6027450"/>
-            <a:ext cx="10172930" cy="246221"/>
-          </a:xfrm>
-          <a:prstGeom prst="rect">
-            <a:avLst/>
-          </a:prstGeom>
-          <a:noFill/>
-        </p:spPr>
-        <p:txBody>
-          <a:bodyPr wrap="square">
-            <a:spAutoFit/>
-          </a:bodyPr>
-          <a:lstStyle/>
-          <a:p>
-            <a:r>
-              <a:rPr lang="en-US" sz="1000" b="1" dirty="0">
-                <a:latin typeface="Consolas" panose="020B0609020204030204" pitchFamily="49" charset="0"/>
-              </a:rPr>
-              <a:t>Warning</a:t>
-            </a:r>
-            <a:r>
-              <a:rPr lang="en-US" sz="1000" dirty="0">
-                <a:latin typeface="Consolas" panose="020B0609020204030204" pitchFamily="49" charset="0"/>
-              </a:rPr>
-              <a:t>: windows and mac/</a:t>
-            </a:r>
-            <a:r>
-              <a:rPr lang="en-US" sz="1000" dirty="0" err="1">
-                <a:latin typeface="Consolas" panose="020B0609020204030204" pitchFamily="49" charset="0"/>
-              </a:rPr>
-              <a:t>linux</a:t>
-            </a:r>
-            <a:r>
-              <a:rPr lang="en-US" sz="1000" dirty="0">
-                <a:latin typeface="Consolas" panose="020B0609020204030204" pitchFamily="49" charset="0"/>
-              </a:rPr>
-              <a:t> have tools called </a:t>
-            </a:r>
-            <a:r>
-              <a:rPr lang="en-US" sz="1000" i="1" dirty="0">
-                <a:latin typeface="Consolas" panose="020B0609020204030204" pitchFamily="49" charset="0"/>
-              </a:rPr>
-              <a:t>curl</a:t>
-            </a:r>
-            <a:r>
-              <a:rPr lang="en-US" sz="1000" dirty="0">
-                <a:latin typeface="Consolas" panose="020B0609020204030204" pitchFamily="49" charset="0"/>
-              </a:rPr>
-              <a:t>, but they seem to be slightly different</a:t>
-            </a:r>
-          </a:p>
-        </p:txBody>
-      </p:sp>
-    </p:spTree>
-    <p:extLst>
-      <p:ext uri="{BB962C8B-B14F-4D97-AF65-F5344CB8AC3E}">
-        <p14:creationId xmlns:p14="http://schemas.microsoft.com/office/powerpoint/2010/main" val="923356200"/>
       </p:ext>
     </p:extLst>
   </p:cSld>
@@ -22029,13 +22166,16 @@
               </a:rPr>
               <a:t>FastAPI</a:t>
             </a:r>
-            <a:endParaRPr lang="en-US" sz="1600" b="0" dirty="0">
-              <a:solidFill>
-                <a:srgbClr val="333333"/>
-              </a:solidFill>
-              <a:effectLst/>
-              <a:latin typeface="Consolas" panose="020B0609020204030204" pitchFamily="49" charset="0"/>
-            </a:endParaRPr>
+            <a:r>
+              <a:rPr lang="en-US" sz="1600" b="0" dirty="0">
+                <a:solidFill>
+                  <a:srgbClr val="333333"/>
+                </a:solidFill>
+                <a:effectLst/>
+                <a:latin typeface="Consolas" panose="020B0609020204030204" pitchFamily="49" charset="0"/>
+              </a:rPr>
+              <a:t>()</a:t>
+            </a:r>
           </a:p>
           <a:p>
             <a:pPr>
@@ -24024,13 +24164,13 @@
           <p:nvPr/>
         </p:nvPicPr>
         <p:blipFill>
-          <a:blip r:embed="rId2">
+          <a:blip>
             <a:extLst>
               <a:ext uri="{28A0092B-C50C-407E-A947-70E740481C1C}">
                 <a14:useLocalDpi xmlns:a14="http://schemas.microsoft.com/office/drawing/2010/main" val="0"/>
               </a:ext>
               <a:ext uri="{96DAC541-7B7A-43D3-8B79-37D633B846F1}">
-                <asvg:svgBlip xmlns:asvg="http://schemas.microsoft.com/office/drawing/2016/SVG/main" r:embed="rId3"/>
+                <asvg:svgBlip xmlns:asvg="http://schemas.microsoft.com/office/drawing/2016/SVG/main" r:embed="rId2"/>
               </a:ext>
             </a:extLst>
           </a:blip>
@@ -24063,13 +24203,13 @@
           <p:nvPr/>
         </p:nvPicPr>
         <p:blipFill>
-          <a:blip r:embed="rId4">
+          <a:blip>
             <a:extLst>
               <a:ext uri="{28A0092B-C50C-407E-A947-70E740481C1C}">
                 <a14:useLocalDpi xmlns:a14="http://schemas.microsoft.com/office/drawing/2010/main" val="0"/>
               </a:ext>
               <a:ext uri="{96DAC541-7B7A-43D3-8B79-37D633B846F1}">
-                <asvg:svgBlip xmlns:asvg="http://schemas.microsoft.com/office/drawing/2016/SVG/main" r:embed="rId5"/>
+                <asvg:svgBlip xmlns:asvg="http://schemas.microsoft.com/office/drawing/2016/SVG/main" r:embed="rId3"/>
               </a:ext>
             </a:extLst>
           </a:blip>
@@ -24102,13 +24242,13 @@
           <p:nvPr/>
         </p:nvPicPr>
         <p:blipFill>
-          <a:blip r:embed="rId6">
+          <a:blip>
             <a:extLst>
               <a:ext uri="{28A0092B-C50C-407E-A947-70E740481C1C}">
                 <a14:useLocalDpi xmlns:a14="http://schemas.microsoft.com/office/drawing/2010/main" val="0"/>
               </a:ext>
               <a:ext uri="{96DAC541-7B7A-43D3-8B79-37D633B846F1}">
-                <asvg:svgBlip xmlns:asvg="http://schemas.microsoft.com/office/drawing/2016/SVG/main" r:embed="rId7"/>
+                <asvg:svgBlip xmlns:asvg="http://schemas.microsoft.com/office/drawing/2016/SVG/main" r:embed="rId4"/>
               </a:ext>
             </a:extLst>
           </a:blip>
@@ -24268,13 +24408,13 @@
           <p:nvPr/>
         </p:nvPicPr>
         <p:blipFill>
-          <a:blip r:embed="rId2">
+          <a:blip>
             <a:extLst>
               <a:ext uri="{28A0092B-C50C-407E-A947-70E740481C1C}">
                 <a14:useLocalDpi xmlns:a14="http://schemas.microsoft.com/office/drawing/2010/main" val="0"/>
               </a:ext>
               <a:ext uri="{96DAC541-7B7A-43D3-8B79-37D633B846F1}">
-                <asvg:svgBlip xmlns:asvg="http://schemas.microsoft.com/office/drawing/2016/SVG/main" r:embed="rId3"/>
+                <asvg:svgBlip xmlns:asvg="http://schemas.microsoft.com/office/drawing/2016/SVG/main" r:embed="rId2"/>
               </a:ext>
             </a:extLst>
           </a:blip>
@@ -24307,13 +24447,13 @@
           <p:nvPr/>
         </p:nvPicPr>
         <p:blipFill>
-          <a:blip r:embed="rId2">
+          <a:blip>
             <a:extLst>
               <a:ext uri="{28A0092B-C50C-407E-A947-70E740481C1C}">
                 <a14:useLocalDpi xmlns:a14="http://schemas.microsoft.com/office/drawing/2010/main" val="0"/>
               </a:ext>
               <a:ext uri="{96DAC541-7B7A-43D3-8B79-37D633B846F1}">
-                <asvg:svgBlip xmlns:asvg="http://schemas.microsoft.com/office/drawing/2016/SVG/main" r:embed="rId3"/>
+                <asvg:svgBlip xmlns:asvg="http://schemas.microsoft.com/office/drawing/2016/SVG/main" r:embed="rId2"/>
               </a:ext>
             </a:extLst>
           </a:blip>
@@ -24430,13 +24570,13 @@
           <p:nvPr/>
         </p:nvPicPr>
         <p:blipFill>
-          <a:blip r:embed="rId2">
+          <a:blip>
             <a:extLst>
               <a:ext uri="{28A0092B-C50C-407E-A947-70E740481C1C}">
                 <a14:useLocalDpi xmlns:a14="http://schemas.microsoft.com/office/drawing/2010/main" val="0"/>
               </a:ext>
               <a:ext uri="{96DAC541-7B7A-43D3-8B79-37D633B846F1}">
-                <asvg:svgBlip xmlns:asvg="http://schemas.microsoft.com/office/drawing/2016/SVG/main" r:embed="rId3"/>
+                <asvg:svgBlip xmlns:asvg="http://schemas.microsoft.com/office/drawing/2016/SVG/main" r:embed="rId2"/>
               </a:ext>
             </a:extLst>
           </a:blip>
@@ -24469,13 +24609,13 @@
           <p:nvPr/>
         </p:nvPicPr>
         <p:blipFill>
-          <a:blip r:embed="rId2">
+          <a:blip>
             <a:extLst>
               <a:ext uri="{28A0092B-C50C-407E-A947-70E740481C1C}">
                 <a14:useLocalDpi xmlns:a14="http://schemas.microsoft.com/office/drawing/2010/main" val="0"/>
               </a:ext>
               <a:ext uri="{96DAC541-7B7A-43D3-8B79-37D633B846F1}">
-                <asvg:svgBlip xmlns:asvg="http://schemas.microsoft.com/office/drawing/2016/SVG/main" r:embed="rId3"/>
+                <asvg:svgBlip xmlns:asvg="http://schemas.microsoft.com/office/drawing/2016/SVG/main" r:embed="rId2"/>
               </a:ext>
             </a:extLst>
           </a:blip>
@@ -24508,13 +24648,13 @@
           <p:nvPr/>
         </p:nvPicPr>
         <p:blipFill>
-          <a:blip r:embed="rId2">
+          <a:blip>
             <a:extLst>
               <a:ext uri="{28A0092B-C50C-407E-A947-70E740481C1C}">
                 <a14:useLocalDpi xmlns:a14="http://schemas.microsoft.com/office/drawing/2010/main" val="0"/>
               </a:ext>
               <a:ext uri="{96DAC541-7B7A-43D3-8B79-37D633B846F1}">
-                <asvg:svgBlip xmlns:asvg="http://schemas.microsoft.com/office/drawing/2016/SVG/main" r:embed="rId3"/>
+                <asvg:svgBlip xmlns:asvg="http://schemas.microsoft.com/office/drawing/2016/SVG/main" r:embed="rId2"/>
               </a:ext>
             </a:extLst>
           </a:blip>
@@ -29559,13 +29699,13 @@
           <p:nvPr/>
         </p:nvPicPr>
         <p:blipFill>
-          <a:blip r:embed="rId2">
+          <a:blip>
             <a:extLst>
               <a:ext uri="{28A0092B-C50C-407E-A947-70E740481C1C}">
                 <a14:useLocalDpi xmlns:a14="http://schemas.microsoft.com/office/drawing/2010/main" val="0"/>
               </a:ext>
               <a:ext uri="{96DAC541-7B7A-43D3-8B79-37D633B846F1}">
-                <asvg:svgBlip xmlns:asvg="http://schemas.microsoft.com/office/drawing/2016/SVG/main" r:embed="rId3"/>
+                <asvg:svgBlip xmlns:asvg="http://schemas.microsoft.com/office/drawing/2016/SVG/main" r:embed="rId2"/>
               </a:ext>
             </a:extLst>
           </a:blip>
@@ -29838,7 +29978,7 @@
           <p:nvPr/>
         </p:nvPicPr>
         <p:blipFill>
-          <a:blip r:embed="rId4"/>
+          <a:blip r:embed="rId3"/>
           <a:stretch>
             <a:fillRect/>
           </a:stretch>

</xml_diff>